<commit_message>
Add GitHub repository URL to all final deliverables
- Final_Presentation.html: Thank You page now shows three columns (Live URL / Source Code / Demo Account)
- Final_Presentation.pptx: closing slide includes GitHub URL bar
- Final_Project_Report.docx: cover page metadata + Appendix A reference
- Updated generation scripts accordingly
</commit_message>
<xml_diff>
--- a/Final_Presentation.pptx
+++ b/Final_Presentation.pptx
@@ -4899,8 +4899,8 @@
         </p:nvSpPr>
         <p:spPr>
           <a:xfrm>
-            <a:off x="731520" y="5669280"/>
-            <a:ext cx="7315200" cy="640080"/>
+            <a:off x="731520" y="5486400"/>
+            <a:ext cx="10972800" cy="502920"/>
           </a:xfrm>
           <a:prstGeom prst="rect">
             <a:avLst/>
@@ -4943,8 +4943,8 @@
         </p:nvSpPr>
         <p:spPr>
           <a:xfrm>
-            <a:off x="914400" y="5669280"/>
-            <a:ext cx="1828800" cy="640080"/>
+            <a:off x="914400" y="5486400"/>
+            <a:ext cx="1828800" cy="502920"/>
           </a:xfrm>
           <a:prstGeom prst="rect">
             <a:avLst/>
@@ -4959,13 +4959,13 @@
           <a:p>
             <a:pPr algn="l"/>
             <a:r>
-              <a:rPr sz="1000" b="1" i="0" spc="300">
+              <a:rPr sz="900" b="1" i="0" spc="300">
                 <a:solidFill>
                   <a:srgbClr val="D4A017"/>
                 </a:solidFill>
                 <a:latin typeface="Consolas"/>
               </a:rPr>
-              <a:t>VISIT</a:t>
+              <a:t>🌐 LIVE</a:t>
             </a:r>
           </a:p>
         </p:txBody>
@@ -4978,8 +4978,8 @@
         </p:nvSpPr>
         <p:spPr>
           <a:xfrm>
-            <a:off x="1828800" y="5669280"/>
-            <a:ext cx="6400800" cy="640080"/>
+            <a:off x="2011680" y="5486400"/>
+            <a:ext cx="9601200" cy="502920"/>
           </a:xfrm>
           <a:prstGeom prst="rect">
             <a:avLst/>
@@ -4994,7 +4994,7 @@
           <a:p>
             <a:pPr algn="l"/>
             <a:r>
-              <a:rPr sz="1300" b="0" i="0">
+              <a:rPr sz="1200" b="0" i="0">
                 <a:solidFill>
                   <a:srgbClr val="FFFFFF"/>
                 </a:solidFill>
@@ -5013,14 +5013,14 @@
         </p:nvSpPr>
         <p:spPr>
           <a:xfrm>
-            <a:off x="8229600" y="5669280"/>
-            <a:ext cx="3520440" cy="640080"/>
+            <a:off x="731520" y="6035040"/>
+            <a:ext cx="10972800" cy="502920"/>
           </a:xfrm>
           <a:prstGeom prst="rect">
             <a:avLst/>
           </a:prstGeom>
           <a:solidFill>
-            <a:srgbClr val="D4A017"/>
+            <a:srgbClr val="1A4F7A"/>
           </a:solidFill>
           <a:ln>
             <a:noFill/>
@@ -5057,29 +5057,29 @@
         </p:nvSpPr>
         <p:spPr>
           <a:xfrm>
-            <a:off x="8229600" y="5669280"/>
-            <a:ext cx="3520440" cy="274320"/>
-          </a:xfrm>
-          <a:prstGeom prst="rect">
-            <a:avLst/>
-          </a:prstGeom>
-          <a:noFill/>
-        </p:spPr>
-        <p:txBody>
-          <a:bodyPr wrap="square" lIns="0" rIns="0" tIns="0" bIns="0" anchor="t">
-            <a:spAutoFit/>
-          </a:bodyPr>
-          <a:lstStyle/>
-          <a:p>
-            <a:pPr algn="ctr"/>
+            <a:off x="914400" y="6035040"/>
+            <a:ext cx="1828800" cy="502920"/>
+          </a:xfrm>
+          <a:prstGeom prst="rect">
+            <a:avLst/>
+          </a:prstGeom>
+          <a:noFill/>
+        </p:spPr>
+        <p:txBody>
+          <a:bodyPr wrap="square" lIns="0" rIns="0" tIns="0" bIns="0" anchor="ctr">
+            <a:spAutoFit/>
+          </a:bodyPr>
+          <a:lstStyle/>
+          <a:p>
+            <a:pPr algn="l"/>
             <a:r>
               <a:rPr sz="900" b="1" i="0" spc="300">
                 <a:solidFill>
-                  <a:srgbClr val="0F0F0F"/>
+                  <a:srgbClr val="D4A017"/>
                 </a:solidFill>
                 <a:latin typeface="Consolas"/>
               </a:rPr>
-              <a:t>DEMO LOGIN</a:t>
+              <a:t>⌥ CODE</a:t>
             </a:r>
           </a:p>
         </p:txBody>
@@ -5092,29 +5092,64 @@
         </p:nvSpPr>
         <p:spPr>
           <a:xfrm>
-            <a:off x="8229600" y="5943600"/>
-            <a:ext cx="3520440" cy="365760"/>
-          </a:xfrm>
-          <a:prstGeom prst="rect">
-            <a:avLst/>
-          </a:prstGeom>
-          <a:noFill/>
-        </p:spPr>
-        <p:txBody>
-          <a:bodyPr wrap="square" lIns="0" rIns="0" tIns="0" bIns="0" anchor="t">
-            <a:spAutoFit/>
-          </a:bodyPr>
-          <a:lstStyle/>
-          <a:p>
-            <a:pPr algn="ctr"/>
-            <a:r>
-              <a:rPr sz="1200" b="1" i="0">
-                <a:solidFill>
-                  <a:srgbClr val="0F0F0F"/>
+            <a:off x="2011680" y="6035040"/>
+            <a:ext cx="9601200" cy="502920"/>
+          </a:xfrm>
+          <a:prstGeom prst="rect">
+            <a:avLst/>
+          </a:prstGeom>
+          <a:noFill/>
+        </p:spPr>
+        <p:txBody>
+          <a:bodyPr wrap="square" lIns="0" rIns="0" tIns="0" bIns="0" anchor="ctr">
+            <a:spAutoFit/>
+          </a:bodyPr>
+          <a:lstStyle/>
+          <a:p>
+            <a:pPr algn="l"/>
+            <a:r>
+              <a:rPr sz="1200" b="0" i="0">
+                <a:solidFill>
+                  <a:srgbClr val="FFFFFF"/>
                 </a:solidFill>
                 <a:latin typeface="Consolas"/>
               </a:rPr>
-              <a:t>1230020693 / demo123</a:t>
+              <a:t>github.com/a2318491287-design/campus-resource-platform</a:t>
+            </a:r>
+          </a:p>
+        </p:txBody>
+      </p:sp>
+      <p:sp>
+        <p:nvSpPr>
+          <p:cNvPr id="24" name="TextBox 23"/>
+          <p:cNvSpPr txBox="1"/>
+          <p:nvPr/>
+        </p:nvSpPr>
+        <p:spPr>
+          <a:xfrm>
+            <a:off x="731520" y="5029200"/>
+            <a:ext cx="10972800" cy="365760"/>
+          </a:xfrm>
+          <a:prstGeom prst="rect">
+            <a:avLst/>
+          </a:prstGeom>
+          <a:noFill/>
+        </p:spPr>
+        <p:txBody>
+          <a:bodyPr wrap="square" lIns="0" rIns="0" tIns="0" bIns="0" anchor="t">
+            <a:spAutoFit/>
+          </a:bodyPr>
+          <a:lstStyle/>
+          <a:p>
+            <a:pPr algn="l"/>
+            <a:r>
+              <a:rPr sz="1100" b="0" i="1">
+                <a:solidFill>
+                  <a:srgbClr val="57534E"/>
+                </a:solidFill>
+                <a:latin typeface="Microsoft YaHei"/>
+              </a:rPr>
+              <a:t>演示账号  /  Demo Login:  学号 1230000000  ·  密码 demo123  ·  100 积分立即可用</a:t>
             </a:r>
           </a:p>
         </p:txBody>

</xml_diff>